<commit_message>
Resubmission: replace demo video (6 min) and slides without notes; update descriptions
</commit_message>
<xml_diff>
--- a/presentation/Marrowick_SecureVault_Group_H_Presentation.pptx
+++ b/presentation/Marrowick_SecureVault_Group_H_Presentation.pptx
@@ -577,11 +577,7 @@
           <a:bodyPr/>
           <a:lstStyle/>
           <a:p>
-            <a:r>
-              <a:rPr lang="en-US" dirty="0"/>
-              <a:t>Speaker: Qawiyy (0:00 to 0:20).
-Good afternoon. We are Group H. I am Qawiyy, the cloud security engineer who built and deployed the platform, and this is Saheedat, our security test and compliance analyst, who tested every control. Our project is Marrowick SecureVault: the guardrails around a health analytics data lake.</a:t>
-            </a:r>
+            <a:endParaRPr lang="en-US" dirty="0"/>
           </a:p>
         </p:txBody>
       </p:sp>
@@ -665,11 +661,7 @@
           <a:bodyPr/>
           <a:lstStyle/>
           <a:p>
-            <a:r>
-              <a:rPr lang="en-US" dirty="0"/>
-              <a:t>Speaker: Saheedat (4:55 to 5:40).
-Lake Formation is blocked in the Learner Lab, so we enforced the same rules with role scoped Athena views and tested them by actually attempting the forbidden queries. The clinic analyst sees only Clinic A, 191 rows. Asking for Clinic B returns nothing. Asking for the notes field, the one that leaked PII, is refused with COLUMN_NOT_FOUND. The corporate analyst sees all three clinics but neither notes nor patient references, so they cannot link one patient across clinics. Seven of seven passed.</a:t>
-            </a:r>
+            <a:endParaRPr lang="en-US" dirty="0"/>
           </a:p>
         </p:txBody>
       </p:sp>
@@ -753,11 +745,7 @@
           <a:bodyPr/>
           <a:lstStyle/>
           <a:p>
-            <a:r>
-              <a:rPr lang="en-US" dirty="0"/>
-              <a:t>Speaker: Saheedat (5:40 to 6:20).
-We query CloudTrail with Athena. Question one: who accessed Clinic C's curated data? You can see the pipeline copying it in, the Glue crawler reading it, then three analyst queries, each with identity, time and service. Question two lists every bucket security change with who made it and when. Question three found an anomaly: a burst of denied Lake Formation calls, a principal repeatedly probing a security service it is not allowed to use. Times are in UTC.</a:t>
-            </a:r>
+            <a:endParaRPr lang="en-US" dirty="0"/>
           </a:p>
         </p:txBody>
       </p:sp>
@@ -841,11 +829,7 @@
           <a:bodyPr/>
           <a:lstStyle/>
           <a:p>
-            <a:r>
-              <a:rPr lang="en-US" dirty="0"/>
-              <a:t>Speaker: Qawiyy (6:20 to 6:50).
-Three things the lab blocked. IAM role creation, so everything ran as LabRole; we wrote a least privilege policy for each role and marked it design only. Lake Formation, so we used views, which are weaker; our production design pairs Lake Formation filters with an explicit deny on direct S3 access. And tagged principals, so the per tenant bucket policy rules are deployed but untested. What stayed enforced regardless: the key policy, the bucket policies and the gate itself.</a:t>
-            </a:r>
+            <a:endParaRPr lang="en-US" dirty="0"/>
           </a:p>
         </p:txBody>
       </p:sp>
@@ -929,11 +913,7 @@
           <a:bodyPr/>
           <a:lstStyle/>
           <a:p>
-            <a:r>
-              <a:rPr lang="en-US" dirty="0"/>
-              <a:t>Speaker: Saheedat (6:50 to 7:10).
-I mapped each control to a PIPEDA principle. Safeguards, limiting collection and limiting use are strong because we tested them. Accountability and accuracy are partial. Just as important is what we do not cover: consent, individual access, retention rules and Ontario's PHIPA. This is a learning exercise, not a certification.</a:t>
-            </a:r>
+            <a:endParaRPr lang="en-US" dirty="0"/>
           </a:p>
         </p:txBody>
       </p:sp>
@@ -1017,11 +997,7 @@
           <a:bodyPr/>
           <a:lstStyle/>
           <a:p>
-            <a:r>
-              <a:rPr lang="en-US" dirty="0"/>
-              <a:t>Speaker: Saheedat (7:10 to 7:25).
-If a control ever failed, the runbook covers four scenarios. For example, if PII reached curated, we contain it by moving the file to quarantine and cutting access, investigate with audit query one to see who read it, fix the pattern and retest, and then assess whether PIPEDA breach reporting applies.</a:t>
-            </a:r>
+            <a:endParaRPr lang="en-US" dirty="0"/>
           </a:p>
         </p:txBody>
       </p:sp>
@@ -1105,11 +1081,7 @@
           <a:bodyPr/>
           <a:lstStyle/>
           <a:p>
-            <a:r>
-              <a:rPr lang="en-US" dirty="0"/>
-              <a:t>Speaker: Qawiyy (7:25 to 7:45).
-Four lessons. Turn CloudTrail on first, because it only records from that moment. Verify every console default. Make sure a test fails for the right reason; our first encryption test passed by accident. And conventions are not controls. Next we would deploy Lake Formation and per role IAM in a full account, add Macie, alarms, masking and retention rules.</a:t>
-            </a:r>
+            <a:endParaRPr lang="en-US" dirty="0"/>
           </a:p>
         </p:txBody>
       </p:sp>
@@ -1193,11 +1165,7 @@
           <a:bodyPr/>
           <a:lstStyle/>
           <a:p>
-            <a:r>
-              <a:rPr lang="en-US" dirty="0"/>
-              <a:t>Speaker: Saheedat (7:45 to 8:00).
-In short: data encrypted with enforcement, PII blocked end to end with alerts, tenant and column separation tested, and every access auditable, with an honest account of what the lab did not allow. Everything is in our GitHub repository. Thank you, we are happy to take questions.</a:t>
-            </a:r>
+            <a:endParaRPr lang="en-US" dirty="0"/>
           </a:p>
         </p:txBody>
       </p:sp>
@@ -1281,11 +1249,7 @@
           <a:bodyPr/>
           <a:lstStyle/>
           <a:p>
-            <a:r>
-              <a:rPr lang="en-US" dirty="0"/>
-              <a:t>Speaker: Qawiyy (0:20 to 0:35).
-We split the work by role. I built and deployed every component. Saheedat tested every control, analysed the results against the brief and mapped them to compliance principles. We each present the parts we owned.</a:t>
-            </a:r>
+            <a:endParaRPr lang="en-US" dirty="0"/>
           </a:p>
         </p:txBody>
       </p:sp>
@@ -1369,11 +1333,7 @@
           <a:bodyPr/>
           <a:lstStyle/>
           <a:p>
-            <a:r>
-              <a:rPr lang="en-US" dirty="0"/>
-              <a:t>Speaker: Qawiyy (0:35 to 0:45).
-Here is our plan. We start with the problem, then the architecture, then each control with its evidence, including a live run of the PII gate. We finish with governance, lessons and your questions.</a:t>
-            </a:r>
+            <a:endParaRPr lang="en-US" dirty="0"/>
           </a:p>
         </p:txBody>
       </p:sp>
@@ -1457,11 +1417,7 @@
           <a:bodyPr/>
           <a:lstStyle/>
           <a:p>
-            <a:r>
-              <a:rPr lang="en-US" dirty="0"/>
-              <a:t>Speaker: Qawiyy (0:45 to 1:25).
-Marrowick is a fictional health analytics vendor. Three clinics send 615 encounter records. Fourteen of those rows have personal information pasted into a free text notes field, which is exactly what happens in real intake. The platform faces four risks: identifiers in free text, one clinic seeing another clinic's data, encryption that can be weakened, and no proof of who accessed what. Our job was not the analytics. It was the guardrails, and proving they hold.</a:t>
-            </a:r>
+            <a:endParaRPr lang="en-US" dirty="0"/>
           </a:p>
         </p:txBody>
       </p:sp>
@@ -1545,11 +1501,7 @@
           <a:bodyPr/>
           <a:lstStyle/>
           <a:p>
-            <a:r>
-              <a:rPr lang="en-US" dirty="0"/>
-              <a:t>Speaker: Qawiyy (1:25 to 1:50).
-We set four objectives, each with a pass condition we could test: enforced encryption, an automated PII gate, separation between clinics and between roles, and an audit trail. Around those we built a governance package.</a:t>
-            </a:r>
+            <a:endParaRPr lang="en-US" dirty="0"/>
           </a:p>
         </p:txBody>
       </p:sp>
@@ -1633,11 +1585,7 @@
           <a:bodyPr/>
           <a:lstStyle/>
           <a:p>
-            <a:r>
-              <a:rPr lang="en-US" dirty="0"/>
-              <a:t>Speaker: Qawiyy (1:50 to 2:40).
-Each clinic uploads a CSV into its own folder in the raw bucket. A Step Functions workflow runs a Lambda that scans the batch. A clean batch is copied to the curated zone; a batch with PII is copied to quarantine and the security team gets an SNS email. A Glue crawler catalogs only the curated zone, and analysts query it through role scoped Athena views. CloudTrail runs underneath everything and we query its logs with Athena. One customer managed KMS key encrypts all three zones.</a:t>
-            </a:r>
+            <a:endParaRPr lang="en-US" dirty="0"/>
           </a:p>
         </p:txBody>
       </p:sp>
@@ -1721,11 +1669,7 @@
           <a:bodyPr/>
           <a:lstStyle/>
           <a:p>
-            <a:r>
-              <a:rPr lang="en-US" dirty="0"/>
-              <a:t>Speaker: Qawiyy (2:40 to 3:20).
-Every tenant bucket uses our customer managed key. The key policy separates duties: a human operator administers the key while the pipeline role can only use it, and rotation is automatic every year. But default encryption can be overridden on upload, so each bucket policy denies non HTTPS traffic, non KMS uploads and any other key. Here is the proof: an upload that asked for weaker SSE-S3 encryption was refused. Saheedat ran this test. Over to Saheedat.</a:t>
-            </a:r>
+            <a:endParaRPr lang="en-US" dirty="0"/>
           </a:p>
         </p:txBody>
       </p:sp>
@@ -1809,14 +1753,7 @@
           <a:bodyPr/>
           <a:lstStyle/>
           <a:p>
-            <a:r>
-              <a:rPr lang="en-US" dirty="0"/>
-              <a:t>Speaker: Saheedat (3:20 to 4:30).
-[Switch to the AWS console and start the execution on the Clinic B raw file.]
-This is the hard gate. The Lambda checks every free text field for health card numbers, SIN formatted numbers, emails and street addresses. It found PII, so the Choice state sends the batch to quarantine, notifies the security team, and the run ends in a deliberate failure called PIIDetected. PromoteToCurated never ran.
-[Switch to the inbox.] Here is the alert. It lists the flagged encounter IDs and the finding types, but never the PII values, so the alert itself cannot leak data.
-If the live run fails, play clip 4 from the demo video and keep talking.</a:t>
-            </a:r>
+            <a:endParaRPr lang="en-US" dirty="0"/>
           </a:p>
         </p:txBody>
       </p:sp>
@@ -1900,11 +1837,7 @@
           <a:bodyPr/>
           <a:lstStyle/>
           <a:p>
-            <a:r>
-              <a:rPr lang="en-US" dirty="0"/>
-              <a:t>Speaker: Saheedat (4:30 to 4:55).
-I checked every detection against the instructor answer key. All fourteen seeded rows were flagged and no clean row was flagged, so precision and recall are both 1.00. Health card numbers and emails were the most common leaks. After a data steward redacted only the flagged notes and resubmitted a version 2 file, the same gate promoted all three batches.</a:t>
-            </a:r>
+            <a:endParaRPr lang="en-US" dirty="0"/>
           </a:p>
         </p:txBody>
       </p:sp>
@@ -2129,7 +2062,7 @@
           </a:prstGeom>
           <a:extLst>
             <a:ext uri="{C572A759-6A51-4108-AA02-DFA0A04FC94B}">
-              <ma14:wrappingTextBoxFlag xmlns:ma14="http://schemas.microsoft.com/office/mac/drawingml/2011/main" xmlns="" val="0"/>
+              <ma14:wrappingTextBoxFlag xmlns="" xmlns:ma14="http://schemas.microsoft.com/office/mac/drawingml/2011/main" val="0"/>
             </a:ext>
           </a:extLst>
         </p:spPr>
@@ -2204,7 +2137,7 @@
           </a:prstGeom>
           <a:extLst>
             <a:ext uri="{C572A759-6A51-4108-AA02-DFA0A04FC94B}">
-              <ma14:wrappingTextBoxFlag xmlns:ma14="http://schemas.microsoft.com/office/mac/drawingml/2011/main" xmlns="" val="0"/>
+              <ma14:wrappingTextBoxFlag xmlns="" xmlns:ma14="http://schemas.microsoft.com/office/mac/drawingml/2011/main" val="0"/>
             </a:ext>
           </a:extLst>
         </p:spPr>
@@ -5652,7 +5585,7 @@
           </a:prstGeom>
           <a:extLst>
             <a:ext uri="{C572A759-6A51-4108-AA02-DFA0A04FC94B}">
-              <ma14:wrappingTextBoxFlag xmlns:ma14="http://schemas.microsoft.com/office/mac/drawingml/2011/main" xmlns="" val="0"/>
+              <ma14:wrappingTextBoxFlag xmlns="" xmlns:ma14="http://schemas.microsoft.com/office/mac/drawingml/2011/main" val="0"/>
             </a:ext>
           </a:extLst>
         </p:spPr>
@@ -6233,7 +6166,7 @@
           </a:prstGeom>
           <a:extLst>
             <a:ext uri="{C572A759-6A51-4108-AA02-DFA0A04FC94B}">
-              <ma14:wrappingTextBoxFlag xmlns:ma14="http://schemas.microsoft.com/office/mac/drawingml/2011/main" xmlns="" val="0"/>
+              <ma14:wrappingTextBoxFlag xmlns="" xmlns:ma14="http://schemas.microsoft.com/office/mac/drawingml/2011/main" val="0"/>
             </a:ext>
           </a:extLst>
         </p:spPr>
@@ -7506,7 +7439,7 @@
           </a:prstGeom>
           <a:extLst>
             <a:ext uri="{C572A759-6A51-4108-AA02-DFA0A04FC94B}">
-              <ma14:wrappingTextBoxFlag xmlns:ma14="http://schemas.microsoft.com/office/mac/drawingml/2011/main" xmlns="" val="0"/>
+              <ma14:wrappingTextBoxFlag xmlns="" xmlns:ma14="http://schemas.microsoft.com/office/mac/drawingml/2011/main" val="0"/>
             </a:ext>
           </a:extLst>
         </p:spPr>
@@ -9226,7 +9159,7 @@
           </a:prstGeom>
           <a:extLst>
             <a:ext uri="{C572A759-6A51-4108-AA02-DFA0A04FC94B}">
-              <ma14:wrappingTextBoxFlag xmlns:ma14="http://schemas.microsoft.com/office/mac/drawingml/2011/main" xmlns="" val="0"/>
+              <ma14:wrappingTextBoxFlag xmlns="" xmlns:ma14="http://schemas.microsoft.com/office/mac/drawingml/2011/main" val="0"/>
             </a:ext>
           </a:extLst>
         </p:spPr>
@@ -11096,7 +11029,7 @@
           </a:prstGeom>
           <a:extLst>
             <a:ext uri="{C572A759-6A51-4108-AA02-DFA0A04FC94B}">
-              <ma14:wrappingTextBoxFlag xmlns:ma14="http://schemas.microsoft.com/office/mac/drawingml/2011/main" xmlns="" val="0"/>
+              <ma14:wrappingTextBoxFlag xmlns="" xmlns:ma14="http://schemas.microsoft.com/office/mac/drawingml/2011/main" val="0"/>
             </a:ext>
           </a:extLst>
         </p:spPr>
@@ -12282,7 +12215,7 @@
           </a:prstGeom>
           <a:extLst>
             <a:ext uri="{C572A759-6A51-4108-AA02-DFA0A04FC94B}">
-              <ma14:wrappingTextBoxFlag xmlns:ma14="http://schemas.microsoft.com/office/mac/drawingml/2011/main" xmlns="" val="0"/>
+              <ma14:wrappingTextBoxFlag xmlns="" xmlns:ma14="http://schemas.microsoft.com/office/mac/drawingml/2011/main" val="0"/>
             </a:ext>
           </a:extLst>
         </p:spPr>
@@ -13493,7 +13426,7 @@
           </a:prstGeom>
           <a:extLst>
             <a:ext uri="{C572A759-6A51-4108-AA02-DFA0A04FC94B}">
-              <ma14:wrappingTextBoxFlag xmlns:ma14="http://schemas.microsoft.com/office/mac/drawingml/2011/main" xmlns="" val="0"/>
+              <ma14:wrappingTextBoxFlag xmlns="" xmlns:ma14="http://schemas.microsoft.com/office/mac/drawingml/2011/main" val="0"/>
             </a:ext>
           </a:extLst>
         </p:spPr>
@@ -14548,7 +14481,7 @@
           </a:prstGeom>
           <a:extLst>
             <a:ext uri="{C572A759-6A51-4108-AA02-DFA0A04FC94B}">
-              <ma14:wrappingTextBoxFlag xmlns:ma14="http://schemas.microsoft.com/office/mac/drawingml/2011/main" xmlns="" val="0"/>
+              <ma14:wrappingTextBoxFlag xmlns="" xmlns:ma14="http://schemas.microsoft.com/office/mac/drawingml/2011/main" val="0"/>
             </a:ext>
           </a:extLst>
         </p:spPr>
@@ -15668,7 +15601,7 @@
           </a:prstGeom>
           <a:extLst>
             <a:ext uri="{C572A759-6A51-4108-AA02-DFA0A04FC94B}">
-              <ma14:wrappingTextBoxFlag xmlns:ma14="http://schemas.microsoft.com/office/mac/drawingml/2011/main" xmlns="" val="0"/>
+              <ma14:wrappingTextBoxFlag xmlns="" xmlns:ma14="http://schemas.microsoft.com/office/mac/drawingml/2011/main" val="0"/>
             </a:ext>
           </a:extLst>
         </p:spPr>
@@ -16710,7 +16643,7 @@
           </a:prstGeom>
           <a:extLst>
             <a:ext uri="{C572A759-6A51-4108-AA02-DFA0A04FC94B}">
-              <ma14:wrappingTextBoxFlag xmlns:ma14="http://schemas.microsoft.com/office/mac/drawingml/2011/main" xmlns="" val="0"/>
+              <ma14:wrappingTextBoxFlag xmlns="" xmlns:ma14="http://schemas.microsoft.com/office/mac/drawingml/2011/main" val="0"/>
             </a:ext>
           </a:extLst>
         </p:spPr>
@@ -16880,7 +16813,7 @@
           </a:prstGeom>
           <a:extLst>
             <a:ext uri="{C572A759-6A51-4108-AA02-DFA0A04FC94B}">
-              <ma14:wrappingTextBoxFlag xmlns:ma14="http://schemas.microsoft.com/office/mac/drawingml/2011/main" xmlns="" val="0"/>
+              <ma14:wrappingTextBoxFlag xmlns="" xmlns:ma14="http://schemas.microsoft.com/office/mac/drawingml/2011/main" val="0"/>
             </a:ext>
           </a:extLst>
         </p:spPr>
@@ -17607,7 +17540,7 @@
           </a:prstGeom>
           <a:extLst>
             <a:ext uri="{C572A759-6A51-4108-AA02-DFA0A04FC94B}">
-              <ma14:wrappingTextBoxFlag xmlns:ma14="http://schemas.microsoft.com/office/mac/drawingml/2011/main" xmlns="" val="0"/>
+              <ma14:wrappingTextBoxFlag xmlns="" xmlns:ma14="http://schemas.microsoft.com/office/mac/drawingml/2011/main" val="0"/>
             </a:ext>
           </a:extLst>
         </p:spPr>
@@ -18442,7 +18375,7 @@
           </a:prstGeom>
           <a:extLst>
             <a:ext uri="{C572A759-6A51-4108-AA02-DFA0A04FC94B}">
-              <ma14:wrappingTextBoxFlag xmlns:ma14="http://schemas.microsoft.com/office/mac/drawingml/2011/main" xmlns="" val="0"/>
+              <ma14:wrappingTextBoxFlag xmlns="" xmlns:ma14="http://schemas.microsoft.com/office/mac/drawingml/2011/main" val="0"/>
             </a:ext>
           </a:extLst>
         </p:spPr>
@@ -20570,7 +20503,7 @@
           </a:prstGeom>
           <a:extLst>
             <a:ext uri="{C572A759-6A51-4108-AA02-DFA0A04FC94B}">
-              <ma14:wrappingTextBoxFlag xmlns:ma14="http://schemas.microsoft.com/office/mac/drawingml/2011/main" xmlns="" val="0"/>
+              <ma14:wrappingTextBoxFlag xmlns="" xmlns:ma14="http://schemas.microsoft.com/office/mac/drawingml/2011/main" val="0"/>
             </a:ext>
           </a:extLst>
         </p:spPr>

</xml_diff>